<commit_message>
Cleanup of things found during CW16 training
</commit_message>
<xml_diff>
--- a/docker/01_Basics_of_containers.pptx
+++ b/docker/01_Basics_of_containers.pptx
@@ -3129,7 +3129,7 @@
   <p:clrMapOvr>
     <a:masterClrMapping/>
   </p:clrMapOvr>
-  <p:extLst mod="1">
+  <p:extLst>
     <p:ext uri="{DCECCB84-F9BA-43D5-87BE-67443E8EF086}">
       <p15:sldGuideLst xmlns:p15="http://schemas.microsoft.com/office/powerpoint/2012/main"/>
     </p:ext>
@@ -5798,7 +5798,7 @@
   <p:clrMapOvr>
     <a:masterClrMapping/>
   </p:clrMapOvr>
-  <p:extLst mod="1">
+  <p:extLst>
     <p:ext uri="{DCECCB84-F9BA-43D5-87BE-67443E8EF086}">
       <p15:sldGuideLst xmlns:p15="http://schemas.microsoft.com/office/powerpoint/2012/main"/>
     </p:ext>
@@ -5976,7 +5976,7 @@
   <p:clrMapOvr>
     <a:masterClrMapping/>
   </p:clrMapOvr>
-  <p:extLst mod="1">
+  <p:extLst>
     <p:ext uri="{DCECCB84-F9BA-43D5-87BE-67443E8EF086}">
       <p15:sldGuideLst xmlns:p15="http://schemas.microsoft.com/office/powerpoint/2012/main"/>
     </p:ext>
@@ -8103,7 +8103,7 @@
   <p:clrMapOvr>
     <a:masterClrMapping/>
   </p:clrMapOvr>
-  <p:extLst mod="1">
+  <p:extLst>
     <p:ext uri="{DCECCB84-F9BA-43D5-87BE-67443E8EF086}">
       <p15:sldGuideLst xmlns:p15="http://schemas.microsoft.com/office/powerpoint/2012/main"/>
     </p:ext>
@@ -8529,7 +8529,7 @@
   <p:clrMapOvr>
     <a:masterClrMapping/>
   </p:clrMapOvr>
-  <p:extLst mod="1">
+  <p:extLst>
     <p:ext uri="{DCECCB84-F9BA-43D5-87BE-67443E8EF086}">
       <p15:sldGuideLst xmlns:p15="http://schemas.microsoft.com/office/powerpoint/2012/main"/>
     </p:ext>
@@ -9959,7 +9959,7 @@
       </a:lvl9pPr>
     </p:otherStyle>
   </p:txStyles>
-  <p:extLst mod="1">
+  <p:extLst>
     <p:ext uri="{27BBF7A9-308A-43DC-89C8-2F10F3537804}">
       <p15:sldGuideLst xmlns:p15="http://schemas.microsoft.com/office/powerpoint/2012/main"/>
     </p:ext>
@@ -10001,14 +10001,19 @@
           <a:p>
             <a:r>
               <a:rPr lang="en-US" dirty="0"/>
-              <a:t>Thomas Buchner, STS Infrastructure</a:t>
+              <a:t>Thomas Buchner, Gardener</a:t>
             </a:r>
           </a:p>
           <a:p>
             <a:r>
               <a:rPr lang="en-US" dirty="0"/>
-              <a:t>Hendrik Kahl, SLV ABAP Component Validation</a:t>
-            </a:r>
+              <a:t>Hendrik Kahl</a:t>
+            </a:r>
+            <a:r>
+              <a:rPr lang="en-US"/>
+              <a:t>, Gardener</a:t>
+            </a:r>
+            <a:endParaRPr lang="en-US" dirty="0"/>
           </a:p>
         </p:txBody>
       </p:sp>
@@ -14529,15 +14534,16 @@
             <a:pPr lvl="2"/>
             <a:r>
               <a:rPr lang="en-US" sz="1600" dirty="0"/>
-              <a:t>whitelisting</a:t>
+              <a:t>allow-listing</a:t>
             </a:r>
           </a:p>
           <a:p>
             <a:pPr lvl="2"/>
             <a:r>
-              <a:rPr lang="en-US" sz="1600" dirty="0"/>
-              <a:t>blacklisting</a:t>
-            </a:r>
+              <a:rPr lang="en-US" sz="1600"/>
+              <a:t>deny-listing</a:t>
+            </a:r>
+            <a:endParaRPr lang="en-US" sz="1600" dirty="0"/>
           </a:p>
           <a:p>
             <a:pPr lvl="2"/>
@@ -21176,21 +21182,6 @@
 </file>
 
 <file path=customXml/item1.xml><?xml version="1.0" encoding="utf-8"?>
-<?mso-contentType ?>
-<FormTemplates xmlns="http://schemas.microsoft.com/sharepoint/v3/contenttype/forms">
-  <Display>DocumentLibraryForm</Display>
-  <Edit>DocumentLibraryForm</Edit>
-  <New>DocumentLibraryForm</New>
-</FormTemplates>
-</file>
-
-<file path=customXml/item2.xml><?xml version="1.0" encoding="utf-8"?>
-<p:properties xmlns:p="http://schemas.microsoft.com/office/2006/metadata/properties" xmlns:xsi="http://www.w3.org/2001/XMLSchema-instance" xmlns:pc="http://schemas.microsoft.com/office/infopath/2007/PartnerControls">
-  <documentManagement/>
-</p:properties>
-</file>
-
-<file path=customXml/item3.xml><?xml version="1.0" encoding="utf-8"?>
 <ct:contentTypeSchema xmlns:ct="http://schemas.microsoft.com/office/2006/metadata/contentType" xmlns:ma="http://schemas.microsoft.com/office/2006/metadata/properties/metaAttributes" ct:_="" ma:_="" ma:contentTypeName="Document" ma:contentTypeID="0x0101000983C563634F704D94CF761DBC03EA5F" ma:contentTypeVersion="4" ma:contentTypeDescription="Create a new document." ma:contentTypeScope="" ma:versionID="e67c02ceee4b342f82f59e2cf148f083">
   <xsd:schema xmlns:xsd="http://www.w3.org/2001/XMLSchema" xmlns:xs="http://www.w3.org/2001/XMLSchema" xmlns:p="http://schemas.microsoft.com/office/2006/metadata/properties" xmlns:ns2="a87f7151-1b36-4597-84cf-4d71535204ce" xmlns:ns3="9a5af304-f682-4bdf-b883-32d674d6b4c0" targetNamespace="http://schemas.microsoft.com/office/2006/metadata/properties" ma:root="true" ma:fieldsID="6780043507351d7647e04fb5ca2e6c73" ns2:_="" ns3:_="">
     <xsd:import namespace="a87f7151-1b36-4597-84cf-4d71535204ce"/>
@@ -21355,24 +21346,22 @@
 </ct:contentTypeSchema>
 </file>
 
-<file path=customXml/itemProps1.xml><?xml version="1.0" encoding="utf-8"?>
-<ds:datastoreItem xmlns:ds="http://schemas.openxmlformats.org/officeDocument/2006/customXml" ds:itemID="{770DE74E-E788-4B7B-8551-430ADD5F5AF1}">
-  <ds:schemaRefs>
-    <ds:schemaRef ds:uri="http://schemas.microsoft.com/sharepoint/v3/contenttype/forms"/>
-  </ds:schemaRefs>
-</ds:datastoreItem>
+<file path=customXml/item2.xml><?xml version="1.0" encoding="utf-8"?>
+<?mso-contentType ?>
+<FormTemplates xmlns="http://schemas.microsoft.com/sharepoint/v3/contenttype/forms">
+  <Display>DocumentLibraryForm</Display>
+  <Edit>DocumentLibraryForm</Edit>
+  <New>DocumentLibraryForm</New>
+</FormTemplates>
 </file>
 
-<file path=customXml/itemProps2.xml><?xml version="1.0" encoding="utf-8"?>
-<ds:datastoreItem xmlns:ds="http://schemas.openxmlformats.org/officeDocument/2006/customXml" ds:itemID="{217406A4-AEB7-4645-B093-8758CB486CA4}">
-  <ds:schemaRefs>
-    <ds:schemaRef ds:uri="http://schemas.microsoft.com/office/2006/metadata/properties"/>
-    <ds:schemaRef ds:uri="http://schemas.microsoft.com/office/infopath/2007/PartnerControls"/>
-  </ds:schemaRefs>
-</ds:datastoreItem>
+<file path=customXml/item3.xml><?xml version="1.0" encoding="utf-8"?>
+<p:properties xmlns:p="http://schemas.microsoft.com/office/2006/metadata/properties" xmlns:xsi="http://www.w3.org/2001/XMLSchema-instance" xmlns:pc="http://schemas.microsoft.com/office/infopath/2007/PartnerControls">
+  <documentManagement/>
+</p:properties>
 </file>
 
-<file path=customXml/itemProps3.xml><?xml version="1.0" encoding="utf-8"?>
+<file path=customXml/itemProps1.xml><?xml version="1.0" encoding="utf-8"?>
 <ds:datastoreItem xmlns:ds="http://schemas.openxmlformats.org/officeDocument/2006/customXml" ds:itemID="{48D604B4-A050-47DE-9CC8-2612EC3271AE}">
   <ds:schemaRefs>
     <ds:schemaRef ds:uri="http://schemas.microsoft.com/office/2006/metadata/contentType"/>
@@ -21389,4 +21378,21 @@
     <ds:schemaRef ds:uri="http://schemas.microsoft.com/internal/obd"/>
   </ds:schemaRefs>
 </ds:datastoreItem>
+</file>
+
+<file path=customXml/itemProps2.xml><?xml version="1.0" encoding="utf-8"?>
+<ds:datastoreItem xmlns:ds="http://schemas.openxmlformats.org/officeDocument/2006/customXml" ds:itemID="{770DE74E-E788-4B7B-8551-430ADD5F5AF1}">
+  <ds:schemaRefs>
+    <ds:schemaRef ds:uri="http://schemas.microsoft.com/sharepoint/v3/contenttype/forms"/>
+  </ds:schemaRefs>
+</ds:datastoreItem>
+</file>
+
+<file path=customXml/itemProps3.xml><?xml version="1.0" encoding="utf-8"?>
+<ds:datastoreItem xmlns:ds="http://schemas.openxmlformats.org/officeDocument/2006/customXml" ds:itemID="{217406A4-AEB7-4645-B093-8758CB486CA4}">
+  <ds:schemaRefs>
+    <ds:schemaRef ds:uri="http://schemas.microsoft.com/office/2006/metadata/properties"/>
+    <ds:schemaRef ds:uri="http://schemas.microsoft.com/office/infopath/2007/PartnerControls"/>
+  </ds:schemaRefs>
+</ds:datastoreItem>
 </file>
</xml_diff>